<commit_message>
Created a new curriculum site format using docusourus
</commit_message>
<xml_diff>
--- a/module-01-driving/slides/05-polygon-function.pptx
+++ b/module-01-driving/slides/05-polygon-function.pptx
@@ -5,20 +5,20 @@
     <p:sldMasterId id="2147483648" r:id="rId1"/>
   </p:sldMasterIdLst>
   <p:sldIdLst>
-    <p:sldId id="256" r:id="rId7"/>
-    <p:sldId id="257" r:id="rId8"/>
-    <p:sldId id="258" r:id="rId9"/>
-    <p:sldId id="259" r:id="rId10"/>
-    <p:sldId id="260" r:id="rId11"/>
-    <p:sldId id="261" r:id="rId12"/>
-    <p:sldId id="262" r:id="rId13"/>
-    <p:sldId id="263" r:id="rId14"/>
-    <p:sldId id="264" r:id="rId15"/>
-    <p:sldId id="265" r:id="rId16"/>
-    <p:sldId id="266" r:id="rId17"/>
-    <p:sldId id="267" r:id="rId18"/>
+    <p:sldId id="256" r:id="rId2"/>
+    <p:sldId id="257" r:id="rId3"/>
+    <p:sldId id="258" r:id="rId4"/>
+    <p:sldId id="259" r:id="rId5"/>
+    <p:sldId id="260" r:id="rId6"/>
+    <p:sldId id="261" r:id="rId7"/>
+    <p:sldId id="262" r:id="rId8"/>
+    <p:sldId id="263" r:id="rId9"/>
+    <p:sldId id="264" r:id="rId10"/>
+    <p:sldId id="265" r:id="rId11"/>
+    <p:sldId id="266" r:id="rId12"/>
+    <p:sldId id="267" r:id="rId13"/>
   </p:sldIdLst>
-  <p:sldSz cx="12191695" cy="6858000" type="screen4x3"/>
+  <p:sldSz cx="12192000" cy="6858000"/>
   <p:notesSz cx="6858000" cy="9144000"/>
   <p:defaultTextStyle>
     <a:defPPr>
@@ -115,6 +115,22 @@
       </a:defRPr>
     </a:lvl9pPr>
   </p:defaultTextStyle>
+  <p:extLst>
+    <p:ext uri="{EFAFB233-063F-42B5-8137-9DF3F51BA10A}">
+      <p15:sldGuideLst xmlns:p15="http://schemas.microsoft.com/office/powerpoint/2012/main">
+        <p15:guide id="1" orient="horz" pos="2160">
+          <p15:clr>
+            <a:srgbClr val="A4A3A4"/>
+          </p15:clr>
+        </p15:guide>
+        <p15:guide id="2" pos="2880">
+          <p15:clr>
+            <a:srgbClr val="A4A3A4"/>
+          </p15:clr>
+        </p15:guide>
+      </p15:sldGuideLst>
+    </p:ext>
+  </p:extLst>
 </p:presentation>
 </file>
 
@@ -156,10 +172,9 @@
           <a:lstStyle/>
           <a:p>
             <a:r>
-              <a:rPr lang="en-US" smtClean="0"/>
+              <a:rPr lang="en-US"/>
               <a:t>Click to edit Master title style</a:t>
             </a:r>
-            <a:endParaRPr lang="en-US"/>
           </a:p>
         </p:txBody>
       </p:sp>
@@ -275,10 +290,9 @@
           </a:lstStyle>
           <a:p>
             <a:r>
-              <a:rPr lang="en-US" smtClean="0"/>
+              <a:rPr lang="en-US"/>
               <a:t>Click to edit Master subtitle style</a:t>
             </a:r>
-            <a:endParaRPr lang="en-US"/>
           </a:p>
         </p:txBody>
       </p:sp>
@@ -299,7 +313,7 @@
           <a:p>
             <a:fld id="{5BCAD085-E8A6-8845-BD4E-CB4CCA059FC4}" type="datetimeFigureOut">
               <a:rPr lang="en-US" smtClean="0"/>
-              <a:t>1/27/13</a:t>
+              <a:t>9/9/26</a:t>
             </a:fld>
             <a:endParaRPr lang="en-US"/>
           </a:p>
@@ -393,10 +407,9 @@
           <a:lstStyle/>
           <a:p>
             <a:r>
-              <a:rPr lang="en-US" smtClean="0"/>
+              <a:rPr lang="en-US"/>
               <a:t>Click to edit Master title style</a:t>
             </a:r>
-            <a:endParaRPr lang="en-US"/>
           </a:p>
         </p:txBody>
       </p:sp>
@@ -417,38 +430,37 @@
           <a:p>
             <a:pPr lvl="0"/>
             <a:r>
-              <a:rPr lang="en-US" smtClean="0"/>
+              <a:rPr lang="en-US"/>
               <a:t>Click to edit Master text styles</a:t>
             </a:r>
           </a:p>
           <a:p>
             <a:pPr lvl="1"/>
             <a:r>
-              <a:rPr lang="en-US" smtClean="0"/>
+              <a:rPr lang="en-US"/>
               <a:t>Second level</a:t>
             </a:r>
           </a:p>
           <a:p>
             <a:pPr lvl="2"/>
             <a:r>
-              <a:rPr lang="en-US" smtClean="0"/>
+              <a:rPr lang="en-US"/>
               <a:t>Third level</a:t>
             </a:r>
           </a:p>
           <a:p>
             <a:pPr lvl="3"/>
             <a:r>
-              <a:rPr lang="en-US" smtClean="0"/>
+              <a:rPr lang="en-US"/>
               <a:t>Fourth level</a:t>
             </a:r>
           </a:p>
           <a:p>
             <a:pPr lvl="4"/>
             <a:r>
-              <a:rPr lang="en-US" smtClean="0"/>
+              <a:rPr lang="en-US"/>
               <a:t>Fifth level</a:t>
             </a:r>
-            <a:endParaRPr lang="en-US"/>
           </a:p>
         </p:txBody>
       </p:sp>
@@ -469,7 +481,7 @@
           <a:p>
             <a:fld id="{5BCAD085-E8A6-8845-BD4E-CB4CCA059FC4}" type="datetimeFigureOut">
               <a:rPr lang="en-US" smtClean="0"/>
-              <a:t>1/27/13</a:t>
+              <a:t>9/9/26</a:t>
             </a:fld>
             <a:endParaRPr lang="en-US"/>
           </a:p>
@@ -568,10 +580,9 @@
           <a:lstStyle/>
           <a:p>
             <a:r>
-              <a:rPr lang="en-US" smtClean="0"/>
+              <a:rPr lang="en-US"/>
               <a:t>Click to edit Master title style</a:t>
             </a:r>
-            <a:endParaRPr lang="en-US"/>
           </a:p>
         </p:txBody>
       </p:sp>
@@ -597,38 +608,37 @@
           <a:p>
             <a:pPr lvl="0"/>
             <a:r>
-              <a:rPr lang="en-US" smtClean="0"/>
+              <a:rPr lang="en-US"/>
               <a:t>Click to edit Master text styles</a:t>
             </a:r>
           </a:p>
           <a:p>
             <a:pPr lvl="1"/>
             <a:r>
-              <a:rPr lang="en-US" smtClean="0"/>
+              <a:rPr lang="en-US"/>
               <a:t>Second level</a:t>
             </a:r>
           </a:p>
           <a:p>
             <a:pPr lvl="2"/>
             <a:r>
-              <a:rPr lang="en-US" smtClean="0"/>
+              <a:rPr lang="en-US"/>
               <a:t>Third level</a:t>
             </a:r>
           </a:p>
           <a:p>
             <a:pPr lvl="3"/>
             <a:r>
-              <a:rPr lang="en-US" smtClean="0"/>
+              <a:rPr lang="en-US"/>
               <a:t>Fourth level</a:t>
             </a:r>
           </a:p>
           <a:p>
             <a:pPr lvl="4"/>
             <a:r>
-              <a:rPr lang="en-US" smtClean="0"/>
+              <a:rPr lang="en-US"/>
               <a:t>Fifth level</a:t>
             </a:r>
-            <a:endParaRPr lang="en-US"/>
           </a:p>
         </p:txBody>
       </p:sp>
@@ -649,7 +659,7 @@
           <a:p>
             <a:fld id="{5BCAD085-E8A6-8845-BD4E-CB4CCA059FC4}" type="datetimeFigureOut">
               <a:rPr lang="en-US" smtClean="0"/>
-              <a:t>1/27/13</a:t>
+              <a:t>9/9/26</a:t>
             </a:fld>
             <a:endParaRPr lang="en-US"/>
           </a:p>
@@ -743,10 +753,9 @@
           <a:lstStyle/>
           <a:p>
             <a:r>
-              <a:rPr lang="en-US" smtClean="0"/>
+              <a:rPr lang="en-US"/>
               <a:t>Click to edit Master title style</a:t>
             </a:r>
-            <a:endParaRPr lang="en-US"/>
           </a:p>
         </p:txBody>
       </p:sp>
@@ -767,38 +776,37 @@
           <a:p>
             <a:pPr lvl="0"/>
             <a:r>
-              <a:rPr lang="en-US" smtClean="0"/>
+              <a:rPr lang="en-US"/>
               <a:t>Click to edit Master text styles</a:t>
             </a:r>
           </a:p>
           <a:p>
             <a:pPr lvl="1"/>
             <a:r>
-              <a:rPr lang="en-US" smtClean="0"/>
+              <a:rPr lang="en-US"/>
               <a:t>Second level</a:t>
             </a:r>
           </a:p>
           <a:p>
             <a:pPr lvl="2"/>
             <a:r>
-              <a:rPr lang="en-US" smtClean="0"/>
+              <a:rPr lang="en-US"/>
               <a:t>Third level</a:t>
             </a:r>
           </a:p>
           <a:p>
             <a:pPr lvl="3"/>
             <a:r>
-              <a:rPr lang="en-US" smtClean="0"/>
+              <a:rPr lang="en-US"/>
               <a:t>Fourth level</a:t>
             </a:r>
           </a:p>
           <a:p>
             <a:pPr lvl="4"/>
             <a:r>
-              <a:rPr lang="en-US" smtClean="0"/>
+              <a:rPr lang="en-US"/>
               <a:t>Fifth level</a:t>
             </a:r>
-            <a:endParaRPr lang="en-US"/>
           </a:p>
         </p:txBody>
       </p:sp>
@@ -819,7 +827,7 @@
           <a:p>
             <a:fld id="{5BCAD085-E8A6-8845-BD4E-CB4CCA059FC4}" type="datetimeFigureOut">
               <a:rPr lang="en-US" smtClean="0"/>
-              <a:t>1/27/13</a:t>
+              <a:t>9/9/26</a:t>
             </a:fld>
             <a:endParaRPr lang="en-US"/>
           </a:p>
@@ -922,10 +930,9 @@
           </a:lstStyle>
           <a:p>
             <a:r>
-              <a:rPr lang="en-US" smtClean="0"/>
+              <a:rPr lang="en-US"/>
               <a:t>Click to edit Master title style</a:t>
             </a:r>
-            <a:endParaRPr lang="en-US"/>
           </a:p>
         </p:txBody>
       </p:sp>
@@ -1042,7 +1049,7 @@
           <a:p>
             <a:pPr lvl="0"/>
             <a:r>
-              <a:rPr lang="en-US" smtClean="0"/>
+              <a:rPr lang="en-US"/>
               <a:t>Click to edit Master text styles</a:t>
             </a:r>
           </a:p>
@@ -1065,7 +1072,7 @@
           <a:p>
             <a:fld id="{5BCAD085-E8A6-8845-BD4E-CB4CCA059FC4}" type="datetimeFigureOut">
               <a:rPr lang="en-US" smtClean="0"/>
-              <a:t>1/27/13</a:t>
+              <a:t>9/9/26</a:t>
             </a:fld>
             <a:endParaRPr lang="en-US"/>
           </a:p>
@@ -1159,10 +1166,9 @@
           <a:lstStyle/>
           <a:p>
             <a:r>
-              <a:rPr lang="en-US" smtClean="0"/>
+              <a:rPr lang="en-US"/>
               <a:t>Click to edit Master title style</a:t>
             </a:r>
-            <a:endParaRPr lang="en-US"/>
           </a:p>
         </p:txBody>
       </p:sp>
@@ -1216,38 +1222,37 @@
           <a:p>
             <a:pPr lvl="0"/>
             <a:r>
-              <a:rPr lang="en-US" smtClean="0"/>
+              <a:rPr lang="en-US"/>
               <a:t>Click to edit Master text styles</a:t>
             </a:r>
           </a:p>
           <a:p>
             <a:pPr lvl="1"/>
             <a:r>
-              <a:rPr lang="en-US" smtClean="0"/>
+              <a:rPr lang="en-US"/>
               <a:t>Second level</a:t>
             </a:r>
           </a:p>
           <a:p>
             <a:pPr lvl="2"/>
             <a:r>
-              <a:rPr lang="en-US" smtClean="0"/>
+              <a:rPr lang="en-US"/>
               <a:t>Third level</a:t>
             </a:r>
           </a:p>
           <a:p>
             <a:pPr lvl="3"/>
             <a:r>
-              <a:rPr lang="en-US" smtClean="0"/>
+              <a:rPr lang="en-US"/>
               <a:t>Fourth level</a:t>
             </a:r>
           </a:p>
           <a:p>
             <a:pPr lvl="4"/>
             <a:r>
-              <a:rPr lang="en-US" smtClean="0"/>
+              <a:rPr lang="en-US"/>
               <a:t>Fifth level</a:t>
             </a:r>
-            <a:endParaRPr lang="en-US"/>
           </a:p>
         </p:txBody>
       </p:sp>
@@ -1301,38 +1306,37 @@
           <a:p>
             <a:pPr lvl="0"/>
             <a:r>
-              <a:rPr lang="en-US" smtClean="0"/>
+              <a:rPr lang="en-US"/>
               <a:t>Click to edit Master text styles</a:t>
             </a:r>
           </a:p>
           <a:p>
             <a:pPr lvl="1"/>
             <a:r>
-              <a:rPr lang="en-US" smtClean="0"/>
+              <a:rPr lang="en-US"/>
               <a:t>Second level</a:t>
             </a:r>
           </a:p>
           <a:p>
             <a:pPr lvl="2"/>
             <a:r>
-              <a:rPr lang="en-US" smtClean="0"/>
+              <a:rPr lang="en-US"/>
               <a:t>Third level</a:t>
             </a:r>
           </a:p>
           <a:p>
             <a:pPr lvl="3"/>
             <a:r>
-              <a:rPr lang="en-US" smtClean="0"/>
+              <a:rPr lang="en-US"/>
               <a:t>Fourth level</a:t>
             </a:r>
           </a:p>
           <a:p>
             <a:pPr lvl="4"/>
             <a:r>
-              <a:rPr lang="en-US" smtClean="0"/>
+              <a:rPr lang="en-US"/>
               <a:t>Fifth level</a:t>
             </a:r>
-            <a:endParaRPr lang="en-US"/>
           </a:p>
         </p:txBody>
       </p:sp>
@@ -1353,7 +1357,7 @@
           <a:p>
             <a:fld id="{5BCAD085-E8A6-8845-BD4E-CB4CCA059FC4}" type="datetimeFigureOut">
               <a:rPr lang="en-US" smtClean="0"/>
-              <a:t>1/27/13</a:t>
+              <a:t>9/9/26</a:t>
             </a:fld>
             <a:endParaRPr lang="en-US"/>
           </a:p>
@@ -1451,10 +1455,9 @@
           </a:lstStyle>
           <a:p>
             <a:r>
-              <a:rPr lang="en-US" smtClean="0"/>
+              <a:rPr lang="en-US"/>
               <a:t>Click to edit Master title style</a:t>
             </a:r>
-            <a:endParaRPr lang="en-US"/>
           </a:p>
         </p:txBody>
       </p:sp>
@@ -1517,7 +1520,7 @@
           <a:p>
             <a:pPr lvl="0"/>
             <a:r>
-              <a:rPr lang="en-US" smtClean="0"/>
+              <a:rPr lang="en-US"/>
               <a:t>Click to edit Master text styles</a:t>
             </a:r>
           </a:p>
@@ -1573,38 +1576,37 @@
           <a:p>
             <a:pPr lvl="0"/>
             <a:r>
-              <a:rPr lang="en-US" smtClean="0"/>
+              <a:rPr lang="en-US"/>
               <a:t>Click to edit Master text styles</a:t>
             </a:r>
           </a:p>
           <a:p>
             <a:pPr lvl="1"/>
             <a:r>
-              <a:rPr lang="en-US" smtClean="0"/>
+              <a:rPr lang="en-US"/>
               <a:t>Second level</a:t>
             </a:r>
           </a:p>
           <a:p>
             <a:pPr lvl="2"/>
             <a:r>
-              <a:rPr lang="en-US" smtClean="0"/>
+              <a:rPr lang="en-US"/>
               <a:t>Third level</a:t>
             </a:r>
           </a:p>
           <a:p>
             <a:pPr lvl="3"/>
             <a:r>
-              <a:rPr lang="en-US" smtClean="0"/>
+              <a:rPr lang="en-US"/>
               <a:t>Fourth level</a:t>
             </a:r>
           </a:p>
           <a:p>
             <a:pPr lvl="4"/>
             <a:r>
-              <a:rPr lang="en-US" smtClean="0"/>
+              <a:rPr lang="en-US"/>
               <a:t>Fifth level</a:t>
             </a:r>
-            <a:endParaRPr lang="en-US"/>
           </a:p>
         </p:txBody>
       </p:sp>
@@ -1667,7 +1669,7 @@
           <a:p>
             <a:pPr lvl="0"/>
             <a:r>
-              <a:rPr lang="en-US" smtClean="0"/>
+              <a:rPr lang="en-US"/>
               <a:t>Click to edit Master text styles</a:t>
             </a:r>
           </a:p>
@@ -1723,38 +1725,37 @@
           <a:p>
             <a:pPr lvl="0"/>
             <a:r>
-              <a:rPr lang="en-US" smtClean="0"/>
+              <a:rPr lang="en-US"/>
               <a:t>Click to edit Master text styles</a:t>
             </a:r>
           </a:p>
           <a:p>
             <a:pPr lvl="1"/>
             <a:r>
-              <a:rPr lang="en-US" smtClean="0"/>
+              <a:rPr lang="en-US"/>
               <a:t>Second level</a:t>
             </a:r>
           </a:p>
           <a:p>
             <a:pPr lvl="2"/>
             <a:r>
-              <a:rPr lang="en-US" smtClean="0"/>
+              <a:rPr lang="en-US"/>
               <a:t>Third level</a:t>
             </a:r>
           </a:p>
           <a:p>
             <a:pPr lvl="3"/>
             <a:r>
-              <a:rPr lang="en-US" smtClean="0"/>
+              <a:rPr lang="en-US"/>
               <a:t>Fourth level</a:t>
             </a:r>
           </a:p>
           <a:p>
             <a:pPr lvl="4"/>
             <a:r>
-              <a:rPr lang="en-US" smtClean="0"/>
+              <a:rPr lang="en-US"/>
               <a:t>Fifth level</a:t>
             </a:r>
-            <a:endParaRPr lang="en-US"/>
           </a:p>
         </p:txBody>
       </p:sp>
@@ -1775,7 +1776,7 @@
           <a:p>
             <a:fld id="{5BCAD085-E8A6-8845-BD4E-CB4CCA059FC4}" type="datetimeFigureOut">
               <a:rPr lang="en-US" smtClean="0"/>
-              <a:t>1/27/13</a:t>
+              <a:t>9/9/26</a:t>
             </a:fld>
             <a:endParaRPr lang="en-US"/>
           </a:p>
@@ -1869,10 +1870,9 @@
           <a:lstStyle/>
           <a:p>
             <a:r>
-              <a:rPr lang="en-US" smtClean="0"/>
+              <a:rPr lang="en-US"/>
               <a:t>Click to edit Master title style</a:t>
             </a:r>
-            <a:endParaRPr lang="en-US"/>
           </a:p>
         </p:txBody>
       </p:sp>
@@ -1893,7 +1893,7 @@
           <a:p>
             <a:fld id="{5BCAD085-E8A6-8845-BD4E-CB4CCA059FC4}" type="datetimeFigureOut">
               <a:rPr lang="en-US" smtClean="0"/>
-              <a:t>1/27/13</a:t>
+              <a:t>9/9/26</a:t>
             </a:fld>
             <a:endParaRPr lang="en-US"/>
           </a:p>
@@ -1988,7 +1988,7 @@
           <a:p>
             <a:fld id="{5BCAD085-E8A6-8845-BD4E-CB4CCA059FC4}" type="datetimeFigureOut">
               <a:rPr lang="en-US" smtClean="0"/>
-              <a:t>1/27/13</a:t>
+              <a:t>9/9/26</a:t>
             </a:fld>
             <a:endParaRPr lang="en-US"/>
           </a:p>
@@ -2091,10 +2091,9 @@
           </a:lstStyle>
           <a:p>
             <a:r>
-              <a:rPr lang="en-US" smtClean="0"/>
+              <a:rPr lang="en-US"/>
               <a:t>Click to edit Master title style</a:t>
             </a:r>
-            <a:endParaRPr lang="en-US"/>
           </a:p>
         </p:txBody>
       </p:sp>
@@ -2148,38 +2147,37 @@
           <a:p>
             <a:pPr lvl="0"/>
             <a:r>
-              <a:rPr lang="en-US" smtClean="0"/>
+              <a:rPr lang="en-US"/>
               <a:t>Click to edit Master text styles</a:t>
             </a:r>
           </a:p>
           <a:p>
             <a:pPr lvl="1"/>
             <a:r>
-              <a:rPr lang="en-US" smtClean="0"/>
+              <a:rPr lang="en-US"/>
               <a:t>Second level</a:t>
             </a:r>
           </a:p>
           <a:p>
             <a:pPr lvl="2"/>
             <a:r>
-              <a:rPr lang="en-US" smtClean="0"/>
+              <a:rPr lang="en-US"/>
               <a:t>Third level</a:t>
             </a:r>
           </a:p>
           <a:p>
             <a:pPr lvl="3"/>
             <a:r>
-              <a:rPr lang="en-US" smtClean="0"/>
+              <a:rPr lang="en-US"/>
               <a:t>Fourth level</a:t>
             </a:r>
           </a:p>
           <a:p>
             <a:pPr lvl="4"/>
             <a:r>
-              <a:rPr lang="en-US" smtClean="0"/>
+              <a:rPr lang="en-US"/>
               <a:t>Fifth level</a:t>
             </a:r>
-            <a:endParaRPr lang="en-US"/>
           </a:p>
         </p:txBody>
       </p:sp>
@@ -2242,7 +2240,7 @@
           <a:p>
             <a:pPr lvl="0"/>
             <a:r>
-              <a:rPr lang="en-US" smtClean="0"/>
+              <a:rPr lang="en-US"/>
               <a:t>Click to edit Master text styles</a:t>
             </a:r>
           </a:p>
@@ -2265,7 +2263,7 @@
           <a:p>
             <a:fld id="{5BCAD085-E8A6-8845-BD4E-CB4CCA059FC4}" type="datetimeFigureOut">
               <a:rPr lang="en-US" smtClean="0"/>
-              <a:t>1/27/13</a:t>
+              <a:t>9/9/26</a:t>
             </a:fld>
             <a:endParaRPr lang="en-US"/>
           </a:p>
@@ -2368,10 +2366,9 @@
           </a:lstStyle>
           <a:p>
             <a:r>
-              <a:rPr lang="en-US" smtClean="0"/>
+              <a:rPr lang="en-US"/>
               <a:t>Click to edit Master title style</a:t>
             </a:r>
-            <a:endParaRPr lang="en-US"/>
           </a:p>
         </p:txBody>
       </p:sp>
@@ -2495,7 +2492,7 @@
           <a:p>
             <a:pPr lvl="0"/>
             <a:r>
-              <a:rPr lang="en-US" smtClean="0"/>
+              <a:rPr lang="en-US"/>
               <a:t>Click to edit Master text styles</a:t>
             </a:r>
           </a:p>
@@ -2518,7 +2515,7 @@
           <a:p>
             <a:fld id="{5BCAD085-E8A6-8845-BD4E-CB4CCA059FC4}" type="datetimeFigureOut">
               <a:rPr lang="en-US" smtClean="0"/>
-              <a:t>1/27/13</a:t>
+              <a:t>9/9/26</a:t>
             </a:fld>
             <a:endParaRPr lang="en-US"/>
           </a:p>
@@ -2627,10 +2624,9 @@
           <a:lstStyle/>
           <a:p>
             <a:r>
-              <a:rPr lang="en-US" smtClean="0"/>
+              <a:rPr lang="en-US"/>
               <a:t>Click to edit Master title style</a:t>
             </a:r>
-            <a:endParaRPr lang="en-US"/>
           </a:p>
         </p:txBody>
       </p:sp>
@@ -2661,38 +2657,37 @@
           <a:p>
             <a:pPr lvl="0"/>
             <a:r>
-              <a:rPr lang="en-US" smtClean="0"/>
+              <a:rPr lang="en-US"/>
               <a:t>Click to edit Master text styles</a:t>
             </a:r>
           </a:p>
           <a:p>
             <a:pPr lvl="1"/>
             <a:r>
-              <a:rPr lang="en-US" smtClean="0"/>
+              <a:rPr lang="en-US"/>
               <a:t>Second level</a:t>
             </a:r>
           </a:p>
           <a:p>
             <a:pPr lvl="2"/>
             <a:r>
-              <a:rPr lang="en-US" smtClean="0"/>
+              <a:rPr lang="en-US"/>
               <a:t>Third level</a:t>
             </a:r>
           </a:p>
           <a:p>
             <a:pPr lvl="3"/>
             <a:r>
-              <a:rPr lang="en-US" smtClean="0"/>
+              <a:rPr lang="en-US"/>
               <a:t>Fourth level</a:t>
             </a:r>
           </a:p>
           <a:p>
             <a:pPr lvl="4"/>
             <a:r>
-              <a:rPr lang="en-US" smtClean="0"/>
+              <a:rPr lang="en-US"/>
               <a:t>Fifth level</a:t>
             </a:r>
-            <a:endParaRPr lang="en-US"/>
           </a:p>
         </p:txBody>
       </p:sp>
@@ -2731,7 +2726,7 @@
           <a:p>
             <a:fld id="{5BCAD085-E8A6-8845-BD4E-CB4CCA059FC4}" type="datetimeFigureOut">
               <a:rPr lang="en-US" smtClean="0"/>
-              <a:t>1/27/13</a:t>
+              <a:t>9/9/26</a:t>
             </a:fld>
             <a:endParaRPr lang="en-US"/>
           </a:p>
@@ -3090,7 +3085,7 @@
 </file>
 
 <file path=ppt/slides/slide1.xml><?xml version="1.0" encoding="utf-8"?>
-<p:sld xmlns:a="http://schemas.openxmlformats.org/drawingml/2006/main" xmlns:p="http://schemas.openxmlformats.org/presentationml/2006/main" xmlns:r="http://schemas.openxmlformats.org/officeDocument/2006/relationships">
+<p:sld xmlns:a="http://schemas.openxmlformats.org/drawingml/2006/main" xmlns:r="http://schemas.openxmlformats.org/officeDocument/2006/relationships" xmlns:p="http://schemas.openxmlformats.org/presentationml/2006/main">
   <p:cSld>
     <p:spTree>
       <p:nvGrpSpPr>
@@ -3098,7 +3093,14 @@
         <p:cNvGrpSpPr/>
         <p:nvPr/>
       </p:nvGrpSpPr>
-      <p:grpSpPr/>
+      <p:grpSpPr>
+        <a:xfrm>
+          <a:off x="0" y="0"/>
+          <a:ext cx="0" cy="0"/>
+          <a:chOff x="0" y="0"/>
+          <a:chExt cx="0" cy="0"/>
+        </a:xfrm>
+      </p:grpSpPr>
       <p:sp>
         <p:nvSpPr>
           <p:cNvPr id="2" name="Rectangle 1"/>
@@ -3139,6 +3141,7 @@
           <a:lstStyle/>
           <a:p>
             <a:pPr algn="ctr"/>
+            <a:endParaRPr/>
           </a:p>
         </p:txBody>
       </p:sp>
@@ -3423,7 +3426,7 @@
 </file>
 
 <file path=ppt/slides/slide10.xml><?xml version="1.0" encoding="utf-8"?>
-<p:sld xmlns:a="http://schemas.openxmlformats.org/drawingml/2006/main" xmlns:p="http://schemas.openxmlformats.org/presentationml/2006/main" xmlns:r="http://schemas.openxmlformats.org/officeDocument/2006/relationships">
+<p:sld xmlns:a="http://schemas.openxmlformats.org/drawingml/2006/main" xmlns:r="http://schemas.openxmlformats.org/officeDocument/2006/relationships" xmlns:p="http://schemas.openxmlformats.org/presentationml/2006/main">
   <p:cSld>
     <p:spTree>
       <p:nvGrpSpPr>
@@ -3431,7 +3434,14 @@
         <p:cNvGrpSpPr/>
         <p:nvPr/>
       </p:nvGrpSpPr>
-      <p:grpSpPr/>
+      <p:grpSpPr>
+        <a:xfrm>
+          <a:off x="0" y="0"/>
+          <a:ext cx="0" cy="0"/>
+          <a:chOff x="0" y="0"/>
+          <a:chExt cx="0" cy="0"/>
+        </a:xfrm>
+      </p:grpSpPr>
       <p:sp>
         <p:nvSpPr>
           <p:cNvPr id="2" name="Rectangle 1"/>
@@ -3472,6 +3482,7 @@
           <a:lstStyle/>
           <a:p>
             <a:pPr algn="ctr"/>
+            <a:endParaRPr/>
           </a:p>
         </p:txBody>
       </p:sp>
@@ -3725,6 +3736,7 @@
           <a:lstStyle/>
           <a:p>
             <a:pPr algn="ctr"/>
+            <a:endParaRPr/>
           </a:p>
         </p:txBody>
       </p:sp>
@@ -3873,6 +3885,7 @@
           <a:lstStyle/>
           <a:p>
             <a:pPr algn="ctr"/>
+            <a:endParaRPr/>
           </a:p>
         </p:txBody>
       </p:sp>
@@ -3988,7 +4001,7 @@
 </file>
 
 <file path=ppt/slides/slide11.xml><?xml version="1.0" encoding="utf-8"?>
-<p:sld xmlns:a="http://schemas.openxmlformats.org/drawingml/2006/main" xmlns:p="http://schemas.openxmlformats.org/presentationml/2006/main" xmlns:r="http://schemas.openxmlformats.org/officeDocument/2006/relationships">
+<p:sld xmlns:a="http://schemas.openxmlformats.org/drawingml/2006/main" xmlns:r="http://schemas.openxmlformats.org/officeDocument/2006/relationships" xmlns:p="http://schemas.openxmlformats.org/presentationml/2006/main">
   <p:cSld>
     <p:spTree>
       <p:nvGrpSpPr>
@@ -3996,7 +4009,14 @@
         <p:cNvGrpSpPr/>
         <p:nvPr/>
       </p:nvGrpSpPr>
-      <p:grpSpPr/>
+      <p:grpSpPr>
+        <a:xfrm>
+          <a:off x="0" y="0"/>
+          <a:ext cx="0" cy="0"/>
+          <a:chOff x="0" y="0"/>
+          <a:chExt cx="0" cy="0"/>
+        </a:xfrm>
+      </p:grpSpPr>
       <p:sp>
         <p:nvSpPr>
           <p:cNvPr id="2" name="Rectangle 1"/>
@@ -4037,6 +4057,7 @@
           <a:lstStyle/>
           <a:p>
             <a:pPr algn="ctr"/>
+            <a:endParaRPr/>
           </a:p>
         </p:txBody>
       </p:sp>
@@ -4157,6 +4178,7 @@
                 <a:latin typeface="Calibri"/>
               </a:defRPr>
             </a:pPr>
+            <a:endParaRPr/>
           </a:p>
           <a:p>
             <a:pPr>
@@ -4234,6 +4256,7 @@
                 <a:latin typeface="Calibri"/>
               </a:defRPr>
             </a:pPr>
+            <a:endParaRPr/>
           </a:p>
           <a:p>
             <a:pPr>
@@ -4327,6 +4350,7 @@
                 <a:latin typeface="Calibri"/>
               </a:defRPr>
             </a:pPr>
+            <a:endParaRPr/>
           </a:p>
         </p:txBody>
       </p:sp>
@@ -4339,7 +4363,7 @@
 </file>
 
 <file path=ppt/slides/slide12.xml><?xml version="1.0" encoding="utf-8"?>
-<p:sld xmlns:a="http://schemas.openxmlformats.org/drawingml/2006/main" xmlns:p="http://schemas.openxmlformats.org/presentationml/2006/main" xmlns:r="http://schemas.openxmlformats.org/officeDocument/2006/relationships">
+<p:sld xmlns:a="http://schemas.openxmlformats.org/drawingml/2006/main" xmlns:r="http://schemas.openxmlformats.org/officeDocument/2006/relationships" xmlns:p="http://schemas.openxmlformats.org/presentationml/2006/main">
   <p:cSld>
     <p:spTree>
       <p:nvGrpSpPr>
@@ -4347,7 +4371,14 @@
         <p:cNvGrpSpPr/>
         <p:nvPr/>
       </p:nvGrpSpPr>
-      <p:grpSpPr/>
+      <p:grpSpPr>
+        <a:xfrm>
+          <a:off x="0" y="0"/>
+          <a:ext cx="0" cy="0"/>
+          <a:chOff x="0" y="0"/>
+          <a:chExt cx="0" cy="0"/>
+        </a:xfrm>
+      </p:grpSpPr>
       <p:sp>
         <p:nvSpPr>
           <p:cNvPr id="2" name="Rectangle 1"/>
@@ -4388,6 +4419,7 @@
           <a:lstStyle/>
           <a:p>
             <a:pPr algn="ctr"/>
+            <a:endParaRPr/>
           </a:p>
         </p:txBody>
       </p:sp>
@@ -4585,6 +4617,7 @@
           <a:lstStyle/>
           <a:p>
             <a:pPr algn="ctr"/>
+            <a:endParaRPr/>
           </a:p>
         </p:txBody>
       </p:sp>
@@ -4720,7 +4753,7 @@
 </file>
 
 <file path=ppt/slides/slide2.xml><?xml version="1.0" encoding="utf-8"?>
-<p:sld xmlns:a="http://schemas.openxmlformats.org/drawingml/2006/main" xmlns:p="http://schemas.openxmlformats.org/presentationml/2006/main" xmlns:r="http://schemas.openxmlformats.org/officeDocument/2006/relationships">
+<p:sld xmlns:a="http://schemas.openxmlformats.org/drawingml/2006/main" xmlns:r="http://schemas.openxmlformats.org/officeDocument/2006/relationships" xmlns:p="http://schemas.openxmlformats.org/presentationml/2006/main">
   <p:cSld>
     <p:spTree>
       <p:nvGrpSpPr>
@@ -4728,7 +4761,14 @@
         <p:cNvGrpSpPr/>
         <p:nvPr/>
       </p:nvGrpSpPr>
-      <p:grpSpPr/>
+      <p:grpSpPr>
+        <a:xfrm>
+          <a:off x="0" y="0"/>
+          <a:ext cx="0" cy="0"/>
+          <a:chOff x="0" y="0"/>
+          <a:chExt cx="0" cy="0"/>
+        </a:xfrm>
+      </p:grpSpPr>
       <p:sp>
         <p:nvSpPr>
           <p:cNvPr id="2" name="Rectangle 1"/>
@@ -4769,6 +4809,7 @@
           <a:lstStyle/>
           <a:p>
             <a:pPr algn="ctr"/>
+            <a:endParaRPr/>
           </a:p>
         </p:txBody>
       </p:sp>
@@ -4990,6 +5031,7 @@
           <a:lstStyle/>
           <a:p>
             <a:pPr algn="ctr"/>
+            <a:endParaRPr/>
           </a:p>
         </p:txBody>
       </p:sp>
@@ -5138,6 +5180,7 @@
           <a:lstStyle/>
           <a:p>
             <a:pPr algn="ctr"/>
+            <a:endParaRPr/>
           </a:p>
         </p:txBody>
       </p:sp>
@@ -5189,7 +5232,7 @@
 </file>
 
 <file path=ppt/slides/slide3.xml><?xml version="1.0" encoding="utf-8"?>
-<p:sld xmlns:a="http://schemas.openxmlformats.org/drawingml/2006/main" xmlns:p="http://schemas.openxmlformats.org/presentationml/2006/main" xmlns:r="http://schemas.openxmlformats.org/officeDocument/2006/relationships">
+<p:sld xmlns:a="http://schemas.openxmlformats.org/drawingml/2006/main" xmlns:r="http://schemas.openxmlformats.org/officeDocument/2006/relationships" xmlns:p="http://schemas.openxmlformats.org/presentationml/2006/main">
   <p:cSld>
     <p:spTree>
       <p:nvGrpSpPr>
@@ -5197,7 +5240,14 @@
         <p:cNvGrpSpPr/>
         <p:nvPr/>
       </p:nvGrpSpPr>
-      <p:grpSpPr/>
+      <p:grpSpPr>
+        <a:xfrm>
+          <a:off x="0" y="0"/>
+          <a:ext cx="0" cy="0"/>
+          <a:chOff x="0" y="0"/>
+          <a:chExt cx="0" cy="0"/>
+        </a:xfrm>
+      </p:grpSpPr>
       <p:sp>
         <p:nvSpPr>
           <p:cNvPr id="2" name="Rectangle 1"/>
@@ -5238,6 +5288,7 @@
           <a:lstStyle/>
           <a:p>
             <a:pPr algn="ctr"/>
+            <a:endParaRPr/>
           </a:p>
         </p:txBody>
       </p:sp>
@@ -5355,6 +5406,7 @@
           <a:lstStyle/>
           <a:p>
             <a:pPr algn="ctr"/>
+            <a:endParaRPr/>
           </a:p>
         </p:txBody>
       </p:sp>
@@ -5586,7 +5638,7 @@
 </file>
 
 <file path=ppt/slides/slide4.xml><?xml version="1.0" encoding="utf-8"?>
-<p:sld xmlns:a="http://schemas.openxmlformats.org/drawingml/2006/main" xmlns:p="http://schemas.openxmlformats.org/presentationml/2006/main" xmlns:r="http://schemas.openxmlformats.org/officeDocument/2006/relationships">
+<p:sld xmlns:a="http://schemas.openxmlformats.org/drawingml/2006/main" xmlns:r="http://schemas.openxmlformats.org/officeDocument/2006/relationships" xmlns:p="http://schemas.openxmlformats.org/presentationml/2006/main">
   <p:cSld>
     <p:spTree>
       <p:nvGrpSpPr>
@@ -5594,7 +5646,14 @@
         <p:cNvGrpSpPr/>
         <p:nvPr/>
       </p:nvGrpSpPr>
-      <p:grpSpPr/>
+      <p:grpSpPr>
+        <a:xfrm>
+          <a:off x="0" y="0"/>
+          <a:ext cx="0" cy="0"/>
+          <a:chOff x="0" y="0"/>
+          <a:chExt cx="0" cy="0"/>
+        </a:xfrm>
+      </p:grpSpPr>
       <p:sp>
         <p:nvSpPr>
           <p:cNvPr id="2" name="Rectangle 1"/>
@@ -5635,6 +5694,7 @@
           <a:lstStyle/>
           <a:p>
             <a:pPr algn="ctr"/>
+            <a:endParaRPr/>
           </a:p>
         </p:txBody>
       </p:sp>
@@ -5854,7 +5914,7 @@
         </p:nvSpPr>
         <p:spPr>
           <a:xfrm>
-            <a:off x="548640" y="3291840"/>
+            <a:off x="548640" y="3677802"/>
             <a:ext cx="5303520" cy="1188720"/>
           </a:xfrm>
           <a:prstGeom prst="roundRect">
@@ -5888,6 +5948,7 @@
           <a:lstStyle/>
           <a:p>
             <a:pPr algn="ctr"/>
+            <a:endParaRPr/>
           </a:p>
         </p:txBody>
       </p:sp>
@@ -5899,7 +5960,7 @@
         </p:nvSpPr>
         <p:spPr>
           <a:xfrm>
-            <a:off x="731520" y="3383280"/>
+            <a:off x="731520" y="3677802"/>
             <a:ext cx="4937760" cy="1005840"/>
           </a:xfrm>
           <a:prstGeom prst="rect">
@@ -5925,7 +5986,16 @@
               </a:defRPr>
             </a:pPr>
             <a:r>
-              <a:t>Define draw_triangle with parameters: size, effort</a:t>
+              <a:rPr dirty="0"/>
+              <a:t>Define </a:t>
+            </a:r>
+            <a:r>
+              <a:rPr dirty="0" err="1"/>
+              <a:t>draw_triangle</a:t>
+            </a:r>
+            <a:r>
+              <a:rPr dirty="0"/>
+              <a:t> with parameters: size, effort</a:t>
             </a:r>
           </a:p>
           <a:p>
@@ -5941,6 +6011,7 @@
               </a:defRPr>
             </a:pPr>
             <a:r>
+              <a:rPr dirty="0"/>
               <a:t>  Repeat 3 times:</a:t>
             </a:r>
           </a:p>
@@ -5957,7 +6028,16 @@
               </a:defRPr>
             </a:pPr>
             <a:r>
-              <a:t>    Straight(size, max_effort=effort)</a:t>
+              <a:rPr dirty="0"/>
+              <a:t>    Straight(size, </a:t>
+            </a:r>
+            <a:r>
+              <a:rPr dirty="0" err="1"/>
+              <a:t>max_effort</a:t>
+            </a:r>
+            <a:r>
+              <a:rPr dirty="0"/>
+              <a:t>=effort)</a:t>
             </a:r>
           </a:p>
           <a:p>
@@ -5973,7 +6053,16 @@
               </a:defRPr>
             </a:pPr>
             <a:r>
-              <a:t>    Turn(120, max_effort=effort)</a:t>
+              <a:rPr dirty="0"/>
+              <a:t>    Turn(120, </a:t>
+            </a:r>
+            <a:r>
+              <a:rPr dirty="0" err="1"/>
+              <a:t>max_effort</a:t>
+            </a:r>
+            <a:r>
+              <a:rPr dirty="0"/>
+              <a:t>=effort)</a:t>
             </a:r>
           </a:p>
         </p:txBody>
@@ -5986,7 +6075,7 @@
         </p:nvSpPr>
         <p:spPr>
           <a:xfrm>
-            <a:off x="6217920" y="3291840"/>
+            <a:off x="6156960" y="3677802"/>
             <a:ext cx="5303520" cy="1188720"/>
           </a:xfrm>
           <a:prstGeom prst="roundRect">
@@ -6020,6 +6109,7 @@
           <a:lstStyle/>
           <a:p>
             <a:pPr algn="ctr"/>
+            <a:endParaRPr/>
           </a:p>
         </p:txBody>
       </p:sp>
@@ -6031,7 +6121,7 @@
         </p:nvSpPr>
         <p:spPr>
           <a:xfrm>
-            <a:off x="6400800" y="3383280"/>
+            <a:off x="6339840" y="3677802"/>
             <a:ext cx="4937760" cy="1005840"/>
           </a:xfrm>
           <a:prstGeom prst="rect">
@@ -6057,7 +6147,16 @@
               </a:defRPr>
             </a:pPr>
             <a:r>
-              <a:t>Define draw_square with parameters: size, effort</a:t>
+              <a:rPr dirty="0"/>
+              <a:t>Define </a:t>
+            </a:r>
+            <a:r>
+              <a:rPr dirty="0" err="1"/>
+              <a:t>draw_square</a:t>
+            </a:r>
+            <a:r>
+              <a:rPr dirty="0"/>
+              <a:t> with parameters: size, effort</a:t>
             </a:r>
           </a:p>
           <a:p>
@@ -6073,6 +6172,7 @@
               </a:defRPr>
             </a:pPr>
             <a:r>
+              <a:rPr dirty="0"/>
               <a:t>  Repeat 4 times:</a:t>
             </a:r>
           </a:p>
@@ -6089,7 +6189,16 @@
               </a:defRPr>
             </a:pPr>
             <a:r>
-              <a:t>    Straight(size, max_effort=effort)</a:t>
+              <a:rPr dirty="0"/>
+              <a:t>    Straight(size, </a:t>
+            </a:r>
+            <a:r>
+              <a:rPr dirty="0" err="1"/>
+              <a:t>max_effort</a:t>
+            </a:r>
+            <a:r>
+              <a:rPr dirty="0"/>
+              <a:t>=effort)</a:t>
             </a:r>
           </a:p>
           <a:p>
@@ -6105,7 +6214,16 @@
               </a:defRPr>
             </a:pPr>
             <a:r>
-              <a:t>    Turn(90, max_effort=effort)</a:t>
+              <a:rPr dirty="0"/>
+              <a:t>    Turn(90, </a:t>
+            </a:r>
+            <a:r>
+              <a:rPr dirty="0" err="1"/>
+              <a:t>max_effort</a:t>
+            </a:r>
+            <a:r>
+              <a:rPr dirty="0"/>
+              <a:t>=effort)</a:t>
             </a:r>
           </a:p>
         </p:txBody>
@@ -6119,7 +6237,7 @@
 </file>
 
 <file path=ppt/slides/slide5.xml><?xml version="1.0" encoding="utf-8"?>
-<p:sld xmlns:a="http://schemas.openxmlformats.org/drawingml/2006/main" xmlns:p="http://schemas.openxmlformats.org/presentationml/2006/main" xmlns:r="http://schemas.openxmlformats.org/officeDocument/2006/relationships">
+<p:sld xmlns:a="http://schemas.openxmlformats.org/drawingml/2006/main" xmlns:r="http://schemas.openxmlformats.org/officeDocument/2006/relationships" xmlns:p="http://schemas.openxmlformats.org/presentationml/2006/main">
   <p:cSld>
     <p:spTree>
       <p:nvGrpSpPr>
@@ -6127,7 +6245,14 @@
         <p:cNvGrpSpPr/>
         <p:nvPr/>
       </p:nvGrpSpPr>
-      <p:grpSpPr/>
+      <p:grpSpPr>
+        <a:xfrm>
+          <a:off x="0" y="0"/>
+          <a:ext cx="0" cy="0"/>
+          <a:chOff x="0" y="0"/>
+          <a:chExt cx="0" cy="0"/>
+        </a:xfrm>
+      </p:grpSpPr>
       <p:sp>
         <p:nvSpPr>
           <p:cNvPr id="2" name="Rectangle 1"/>
@@ -6168,6 +6293,7 @@
           <a:lstStyle/>
           <a:p>
             <a:pPr algn="ctr"/>
+            <a:endParaRPr/>
           </a:p>
         </p:txBody>
       </p:sp>
@@ -6285,6 +6411,7 @@
           <a:lstStyle/>
           <a:p>
             <a:pPr algn="ctr"/>
+            <a:endParaRPr/>
           </a:p>
         </p:txBody>
       </p:sp>
@@ -6564,7 +6691,7 @@
 </file>
 
 <file path=ppt/slides/slide6.xml><?xml version="1.0" encoding="utf-8"?>
-<p:sld xmlns:a="http://schemas.openxmlformats.org/drawingml/2006/main" xmlns:p="http://schemas.openxmlformats.org/presentationml/2006/main" xmlns:r="http://schemas.openxmlformats.org/officeDocument/2006/relationships">
+<p:sld xmlns:a="http://schemas.openxmlformats.org/drawingml/2006/main" xmlns:r="http://schemas.openxmlformats.org/officeDocument/2006/relationships" xmlns:p="http://schemas.openxmlformats.org/presentationml/2006/main">
   <p:cSld>
     <p:spTree>
       <p:nvGrpSpPr>
@@ -6572,7 +6699,14 @@
         <p:cNvGrpSpPr/>
         <p:nvPr/>
       </p:nvGrpSpPr>
-      <p:grpSpPr/>
+      <p:grpSpPr>
+        <a:xfrm>
+          <a:off x="0" y="0"/>
+          <a:ext cx="0" cy="0"/>
+          <a:chOff x="0" y="0"/>
+          <a:chExt cx="0" cy="0"/>
+        </a:xfrm>
+      </p:grpSpPr>
       <p:sp>
         <p:nvSpPr>
           <p:cNvPr id="2" name="Rectangle 1"/>
@@ -6613,6 +6747,7 @@
           <a:lstStyle/>
           <a:p>
             <a:pPr algn="ctr"/>
+            <a:endParaRPr/>
           </a:p>
         </p:txBody>
       </p:sp>
@@ -6701,6 +6836,7 @@
                 <a:latin typeface="Calibri"/>
               </a:defRPr>
             </a:pPr>
+            <a:endParaRPr/>
           </a:p>
           <a:p>
             <a:pPr>
@@ -6826,6 +6962,7 @@
                 <a:latin typeface="Calibri"/>
               </a:defRPr>
             </a:pPr>
+            <a:endParaRPr/>
           </a:p>
           <a:p>
             <a:pPr>
@@ -6855,6 +6992,7 @@
                 <a:latin typeface="Calibri"/>
               </a:defRPr>
             </a:pPr>
+            <a:endParaRPr/>
           </a:p>
         </p:txBody>
       </p:sp>
@@ -6867,7 +7005,7 @@
 </file>
 
 <file path=ppt/slides/slide7.xml><?xml version="1.0" encoding="utf-8"?>
-<p:sld xmlns:a="http://schemas.openxmlformats.org/drawingml/2006/main" xmlns:p="http://schemas.openxmlformats.org/presentationml/2006/main" xmlns:r="http://schemas.openxmlformats.org/officeDocument/2006/relationships">
+<p:sld xmlns:a="http://schemas.openxmlformats.org/drawingml/2006/main" xmlns:r="http://schemas.openxmlformats.org/officeDocument/2006/relationships" xmlns:p="http://schemas.openxmlformats.org/presentationml/2006/main">
   <p:cSld>
     <p:spTree>
       <p:nvGrpSpPr>
@@ -6875,7 +7013,14 @@
         <p:cNvGrpSpPr/>
         <p:nvPr/>
       </p:nvGrpSpPr>
-      <p:grpSpPr/>
+      <p:grpSpPr>
+        <a:xfrm>
+          <a:off x="0" y="0"/>
+          <a:ext cx="0" cy="0"/>
+          <a:chOff x="0" y="0"/>
+          <a:chExt cx="0" cy="0"/>
+        </a:xfrm>
+      </p:grpSpPr>
       <p:sp>
         <p:nvSpPr>
           <p:cNvPr id="2" name="Rectangle 1"/>
@@ -6916,6 +7061,7 @@
           <a:lstStyle/>
           <a:p>
             <a:pPr algn="ctr"/>
+            <a:endParaRPr/>
           </a:p>
         </p:txBody>
       </p:sp>
@@ -7084,7 +7230,9 @@
             <a:spAutoFit/>
           </a:bodyPr>
           <a:lstStyle/>
-          <a:p/>
+          <a:p>
+            <a:endParaRPr/>
+          </a:p>
         </p:txBody>
       </p:sp>
       <p:sp>
@@ -7129,6 +7277,7 @@
           <a:lstStyle/>
           <a:p>
             <a:pPr algn="ctr"/>
+            <a:endParaRPr/>
           </a:p>
         </p:txBody>
       </p:sp>
@@ -7293,6 +7442,7 @@
           <a:lstStyle/>
           <a:p>
             <a:pPr algn="ctr"/>
+            <a:endParaRPr/>
           </a:p>
         </p:txBody>
       </p:sp>
@@ -7425,6 +7575,7 @@
           <a:lstStyle/>
           <a:p>
             <a:pPr algn="ctr"/>
+            <a:endParaRPr/>
           </a:p>
         </p:txBody>
       </p:sp>
@@ -7524,7 +7675,7 @@
 </file>
 
 <file path=ppt/slides/slide8.xml><?xml version="1.0" encoding="utf-8"?>
-<p:sld xmlns:a="http://schemas.openxmlformats.org/drawingml/2006/main" xmlns:p="http://schemas.openxmlformats.org/presentationml/2006/main" xmlns:r="http://schemas.openxmlformats.org/officeDocument/2006/relationships">
+<p:sld xmlns:a="http://schemas.openxmlformats.org/drawingml/2006/main" xmlns:r="http://schemas.openxmlformats.org/officeDocument/2006/relationships" xmlns:p="http://schemas.openxmlformats.org/presentationml/2006/main">
   <p:cSld>
     <p:spTree>
       <p:nvGrpSpPr>
@@ -7532,7 +7683,14 @@
         <p:cNvGrpSpPr/>
         <p:nvPr/>
       </p:nvGrpSpPr>
-      <p:grpSpPr/>
+      <p:grpSpPr>
+        <a:xfrm>
+          <a:off x="0" y="0"/>
+          <a:ext cx="0" cy="0"/>
+          <a:chOff x="0" y="0"/>
+          <a:chExt cx="0" cy="0"/>
+        </a:xfrm>
+      </p:grpSpPr>
       <p:sp>
         <p:nvSpPr>
           <p:cNvPr id="2" name="Rectangle 1"/>
@@ -7573,6 +7731,7 @@
           <a:lstStyle/>
           <a:p>
             <a:pPr algn="ctr"/>
+            <a:endParaRPr/>
           </a:p>
         </p:txBody>
       </p:sp>
@@ -7661,6 +7820,7 @@
                 <a:latin typeface="Calibri"/>
               </a:defRPr>
             </a:pPr>
+            <a:endParaRPr/>
           </a:p>
         </p:txBody>
       </p:sp>
@@ -7683,9 +7843,27 @@
                 <a:tableStyleId>{5C22544A-7EE6-4342-B048-85BDC9FD1C3A}</a:tableStyleId>
               </a:tblPr>
               <a:tblGrid>
-                <a:gridCol w="3352800"/>
-                <a:gridCol w="3352800"/>
-                <a:gridCol w="3352800"/>
+                <a:gridCol w="3352800">
+                  <a:extLst>
+                    <a:ext uri="{9D8B030D-6E8A-4147-A177-3AD203B41FA5}">
+                      <a16:colId xmlns:a16="http://schemas.microsoft.com/office/drawing/2014/main" val="20000"/>
+                    </a:ext>
+                  </a:extLst>
+                </a:gridCol>
+                <a:gridCol w="3352800">
+                  <a:extLst>
+                    <a:ext uri="{9D8B030D-6E8A-4147-A177-3AD203B41FA5}">
+                      <a16:colId xmlns:a16="http://schemas.microsoft.com/office/drawing/2014/main" val="20001"/>
+                    </a:ext>
+                  </a:extLst>
+                </a:gridCol>
+                <a:gridCol w="3352800">
+                  <a:extLst>
+                    <a:ext uri="{9D8B030D-6E8A-4147-A177-3AD203B41FA5}">
+                      <a16:colId xmlns:a16="http://schemas.microsoft.com/office/drawing/2014/main" val="20002"/>
+                    </a:ext>
+                  </a:extLst>
+                </a:gridCol>
               </a:tblGrid>
               <a:tr h="365760">
                 <a:tc>
@@ -7760,6 +7938,11 @@
                     </a:solidFill>
                   </a:tcPr>
                 </a:tc>
+                <a:extLst>
+                  <a:ext uri="{0D108BD9-81ED-4DB2-BD59-A6C34878D82A}">
+                    <a16:rowId xmlns:a16="http://schemas.microsoft.com/office/drawing/2014/main" val="10000"/>
+                  </a:ext>
+                </a:extLst>
               </a:tr>
               <a:tr h="365760">
                 <a:tc>
@@ -7813,6 +7996,11 @@
                   </a:txBody>
                   <a:tcPr/>
                 </a:tc>
+                <a:extLst>
+                  <a:ext uri="{0D108BD9-81ED-4DB2-BD59-A6C34878D82A}">
+                    <a16:rowId xmlns:a16="http://schemas.microsoft.com/office/drawing/2014/main" val="10001"/>
+                  </a:ext>
+                </a:extLst>
               </a:tr>
               <a:tr h="365760">
                 <a:tc>
@@ -7878,6 +8066,11 @@
                     </a:solidFill>
                   </a:tcPr>
                 </a:tc>
+                <a:extLst>
+                  <a:ext uri="{0D108BD9-81ED-4DB2-BD59-A6C34878D82A}">
+                    <a16:rowId xmlns:a16="http://schemas.microsoft.com/office/drawing/2014/main" val="10002"/>
+                  </a:ext>
+                </a:extLst>
               </a:tr>
               <a:tr h="365760">
                 <a:tc>
@@ -7931,6 +8124,11 @@
                   </a:txBody>
                   <a:tcPr/>
                 </a:tc>
+                <a:extLst>
+                  <a:ext uri="{0D108BD9-81ED-4DB2-BD59-A6C34878D82A}">
+                    <a16:rowId xmlns:a16="http://schemas.microsoft.com/office/drawing/2014/main" val="10003"/>
+                  </a:ext>
+                </a:extLst>
               </a:tr>
               <a:tr h="365760">
                 <a:tc>
@@ -7996,6 +8194,11 @@
                     </a:solidFill>
                   </a:tcPr>
                 </a:tc>
+                <a:extLst>
+                  <a:ext uri="{0D108BD9-81ED-4DB2-BD59-A6C34878D82A}">
+                    <a16:rowId xmlns:a16="http://schemas.microsoft.com/office/drawing/2014/main" val="10004"/>
+                  </a:ext>
+                </a:extLst>
               </a:tr>
               <a:tr h="365760">
                 <a:tc>
@@ -8049,6 +8252,11 @@
                   </a:txBody>
                   <a:tcPr/>
                 </a:tc>
+                <a:extLst>
+                  <a:ext uri="{0D108BD9-81ED-4DB2-BD59-A6C34878D82A}">
+                    <a16:rowId xmlns:a16="http://schemas.microsoft.com/office/drawing/2014/main" val="10005"/>
+                  </a:ext>
+                </a:extLst>
               </a:tr>
             </a:tbl>
           </a:graphicData>
@@ -8167,6 +8375,7 @@
                 <a:latin typeface="Calibri"/>
               </a:defRPr>
             </a:pPr>
+            <a:endParaRPr/>
           </a:p>
           <a:p>
             <a:pPr>
@@ -8196,6 +8405,7 @@
                 <a:latin typeface="Calibri"/>
               </a:defRPr>
             </a:pPr>
+            <a:endParaRPr/>
           </a:p>
         </p:txBody>
       </p:sp>
@@ -8208,7 +8418,7 @@
 </file>
 
 <file path=ppt/slides/slide9.xml><?xml version="1.0" encoding="utf-8"?>
-<p:sld xmlns:a="http://schemas.openxmlformats.org/drawingml/2006/main" xmlns:p="http://schemas.openxmlformats.org/presentationml/2006/main" xmlns:r="http://schemas.openxmlformats.org/officeDocument/2006/relationships">
+<p:sld xmlns:a="http://schemas.openxmlformats.org/drawingml/2006/main" xmlns:r="http://schemas.openxmlformats.org/officeDocument/2006/relationships" xmlns:p="http://schemas.openxmlformats.org/presentationml/2006/main">
   <p:cSld>
     <p:spTree>
       <p:nvGrpSpPr>
@@ -8216,7 +8426,14 @@
         <p:cNvGrpSpPr/>
         <p:nvPr/>
       </p:nvGrpSpPr>
-      <p:grpSpPr/>
+      <p:grpSpPr>
+        <a:xfrm>
+          <a:off x="0" y="0"/>
+          <a:ext cx="0" cy="0"/>
+          <a:chOff x="0" y="0"/>
+          <a:chExt cx="0" cy="0"/>
+        </a:xfrm>
+      </p:grpSpPr>
       <p:sp>
         <p:nvSpPr>
           <p:cNvPr id="2" name="Rectangle 1"/>
@@ -8257,6 +8474,7 @@
           <a:lstStyle/>
           <a:p>
             <a:pPr algn="ctr"/>
+            <a:endParaRPr/>
           </a:p>
         </p:txBody>
       </p:sp>
@@ -8441,7 +8659,9 @@
             <a:spAutoFit/>
           </a:bodyPr>
           <a:lstStyle/>
-          <a:p/>
+          <a:p>
+            <a:endParaRPr/>
+          </a:p>
         </p:txBody>
       </p:sp>
       <p:sp>
@@ -8486,6 +8706,7 @@
           <a:lstStyle/>
           <a:p>
             <a:pPr algn="ctr"/>
+            <a:endParaRPr/>
           </a:p>
         </p:txBody>
       </p:sp>
@@ -8634,6 +8855,7 @@
           <a:lstStyle/>
           <a:p>
             <a:pPr algn="ctr"/>
+            <a:endParaRPr/>
           </a:p>
         </p:txBody>
       </p:sp>
@@ -8734,6 +8956,7 @@
           <a:lstStyle/>
           <a:p>
             <a:pPr algn="ctr"/>
+            <a:endParaRPr/>
           </a:p>
         </p:txBody>
       </p:sp>

</xml_diff>